<commit_message>
Clarify experiment and evaluation slides without internal terminology
</commit_message>
<xml_diff>
--- a/docs/presentacion_entrevista_postulacion_doctoral_revisada.pptx
+++ b/docs/presentacion_entrevista_postulacion_doctoral_revisada.pptx
@@ -8556,16 +8556,8 @@
                 <a:latin typeface="Arial"/>
                 <a:ea typeface="DejaVu Sans"/>
               </a:rPr>
-              <a:t>ALCANCE EXPERIMENTAL</a:t>
-            </a:r>
-            <a:endParaRPr lang="en-US" sz="1000" b="0" u="none" strike="noStrike">
-              <a:solidFill>
-                <a:srgbClr val="000000"/>
-              </a:solidFill>
-              <a:effectLst/>
-              <a:uFillTx/>
-              <a:latin typeface="Arial"/>
-            </a:endParaRPr>
+              <a:t>EXPERIMENTOS</a:t>
+            </a:r>
           </a:p>
         </p:txBody>
       </p:sp>
@@ -8617,16 +8609,8 @@
                 <a:latin typeface="Times New Roman"/>
                 <a:ea typeface="DejaVu Sans"/>
               </a:rPr>
-              <a:t>Más allá del trading: evaluación en varios dominios</a:t>
-            </a:r>
-            <a:endParaRPr lang="en-US" sz="2900" b="1" u="none" strike="noStrike">
-              <a:solidFill>
-                <a:srgbClr val="000000"/>
-              </a:solidFill>
-              <a:effectLst/>
-              <a:uFillTx/>
-              <a:latin typeface="Arial"/>
-            </a:endParaRPr>
+              <a:t>Qué vamos a probar y en qué datos</a:t>
+            </a:r>
           </a:p>
         </p:txBody>
       </p:sp>
@@ -8929,268 +8913,8 @@
                 <a:latin typeface="Arial"/>
                 <a:ea typeface="DejaVu Sans"/>
               </a:rPr>
-              <a:t>Fa</a:t>
-            </a:r>
-            <a:r>
-              <a:rPr lang="es-CO" sz="2200" b="1" u="none" strike="noStrike">
-                <a:solidFill>
-                  <a:srgbClr val="147D78"/>
-                </a:solidFill>
-                <a:effectLst/>
-                <a:uFillTx/>
-                <a:latin typeface="Arial"/>
-                <a:ea typeface="DejaVu Sans"/>
-              </a:rPr>
-              <a:t>mili</a:t>
-            </a:r>
-            <a:r>
-              <a:rPr lang="es-CO" sz="2200" b="1" u="none" strike="noStrike">
-                <a:solidFill>
-                  <a:srgbClr val="147D78"/>
-                </a:solidFill>
-                <a:effectLst/>
-                <a:uFillTx/>
-                <a:latin typeface="Arial"/>
-                <a:ea typeface="DejaVu Sans"/>
-              </a:rPr>
-              <a:t>as </a:t>
-            </a:r>
-            <a:r>
-              <a:rPr lang="es-CO" sz="2200" b="1" u="none" strike="noStrike">
-                <a:solidFill>
-                  <a:srgbClr val="147D78"/>
-                </a:solidFill>
-                <a:effectLst/>
-                <a:uFillTx/>
-                <a:latin typeface="Arial"/>
-                <a:ea typeface="DejaVu Sans"/>
-              </a:rPr>
-              <a:t>púb</a:t>
-            </a:r>
-            <a:r>
-              <a:rPr lang="es-CO" sz="2200" b="1" u="none" strike="noStrike">
-                <a:solidFill>
-                  <a:srgbClr val="147D78"/>
-                </a:solidFill>
-                <a:effectLst/>
-                <a:uFillTx/>
-                <a:latin typeface="Arial"/>
-                <a:ea typeface="DejaVu Sans"/>
-              </a:rPr>
-              <a:t>lica</a:t>
-            </a:r>
-            <a:r>
-              <a:rPr lang="es-CO" sz="2200" b="1" u="none" strike="noStrike">
-                <a:solidFill>
-                  <a:srgbClr val="147D78"/>
-                </a:solidFill>
-                <a:effectLst/>
-                <a:uFillTx/>
-                <a:latin typeface="Arial"/>
-                <a:ea typeface="DejaVu Sans"/>
-              </a:rPr>
-              <a:t>s </a:t>
-            </a:r>
-            <a:r>
-              <a:rPr lang="es-CO" sz="2200" b="1" u="none" strike="noStrike">
-                <a:solidFill>
-                  <a:srgbClr val="147D78"/>
-                </a:solidFill>
-                <a:effectLst/>
-                <a:uFillTx/>
-                <a:latin typeface="Arial"/>
-                <a:ea typeface="DejaVu Sans"/>
-              </a:rPr>
-              <a:t>de </a:t>
-            </a:r>
-            <a:r>
-              <a:rPr lang="es-CO" sz="2200" b="1" u="none" strike="noStrike">
-                <a:solidFill>
-                  <a:srgbClr val="147D78"/>
-                </a:solidFill>
-                <a:effectLst/>
-                <a:uFillTx/>
-                <a:latin typeface="Arial"/>
-                <a:ea typeface="DejaVu Sans"/>
-              </a:rPr>
-              <a:t>dist</a:t>
-            </a:r>
-            <a:r>
-              <a:rPr lang="es-CO" sz="2200" b="1" u="none" strike="noStrike">
-                <a:solidFill>
-                  <a:srgbClr val="147D78"/>
-                </a:solidFill>
-                <a:effectLst/>
-                <a:uFillTx/>
-                <a:latin typeface="Arial"/>
-                <a:ea typeface="DejaVu Sans"/>
-              </a:rPr>
-              <a:t>into</a:t>
-            </a:r>
-            <a:r>
-              <a:rPr lang="es-CO" sz="2200" b="1" u="none" strike="noStrike">
-                <a:solidFill>
-                  <a:srgbClr val="147D78"/>
-                </a:solidFill>
-                <a:effectLst/>
-                <a:uFillTx/>
-                <a:latin typeface="Arial"/>
-                <a:ea typeface="DejaVu Sans"/>
-              </a:rPr>
-              <a:t>s </a:t>
-            </a:r>
-            <a:r>
-              <a:rPr lang="es-CO" sz="2200" b="1" u="none" strike="noStrike">
-                <a:solidFill>
-                  <a:srgbClr val="147D78"/>
-                </a:solidFill>
-                <a:effectLst/>
-                <a:uFillTx/>
-                <a:latin typeface="Arial"/>
-                <a:ea typeface="DejaVu Sans"/>
-              </a:rPr>
-              <a:t>do</a:t>
-            </a:r>
-            <a:r>
-              <a:rPr lang="es-CO" sz="2200" b="1" u="none" strike="noStrike">
-                <a:solidFill>
-                  <a:srgbClr val="147D78"/>
-                </a:solidFill>
-                <a:effectLst/>
-                <a:uFillTx/>
-                <a:latin typeface="Arial"/>
-                <a:ea typeface="DejaVu Sans"/>
-              </a:rPr>
-              <a:t>min</a:t>
-            </a:r>
-            <a:r>
-              <a:rPr lang="es-CO" sz="2200" b="1" u="none" strike="noStrike">
-                <a:solidFill>
-                  <a:srgbClr val="147D78"/>
-                </a:solidFill>
-                <a:effectLst/>
-                <a:uFillTx/>
-                <a:latin typeface="Arial"/>
-                <a:ea typeface="DejaVu Sans"/>
-              </a:rPr>
-              <a:t>ios, </a:t>
-            </a:r>
-            <a:r>
-              <a:rPr lang="es-CO" sz="2200" b="1" u="none" strike="noStrike">
-                <a:solidFill>
-                  <a:srgbClr val="147D78"/>
-                </a:solidFill>
-                <a:effectLst/>
-                <a:uFillTx/>
-                <a:latin typeface="Arial"/>
-                <a:ea typeface="DejaVu Sans"/>
-              </a:rPr>
-              <a:t>con </a:t>
-            </a:r>
-            <a:r>
-              <a:rPr lang="es-CO" sz="2200" b="1" u="none" strike="noStrike">
-                <a:solidFill>
-                  <a:srgbClr val="147D78"/>
-                </a:solidFill>
-                <a:effectLst/>
-                <a:uFillTx/>
-                <a:latin typeface="Arial"/>
-                <a:ea typeface="DejaVu Sans"/>
-              </a:rPr>
-              <a:t>prot</a:t>
-            </a:r>
-            <a:r>
-              <a:rPr lang="es-CO" sz="2200" b="1" u="none" strike="noStrike">
-                <a:solidFill>
-                  <a:srgbClr val="147D78"/>
-                </a:solidFill>
-                <a:effectLst/>
-                <a:uFillTx/>
-                <a:latin typeface="Arial"/>
-                <a:ea typeface="DejaVu Sans"/>
-              </a:rPr>
-              <a:t>oco</a:t>
-            </a:r>
-            <a:r>
-              <a:rPr lang="es-CO" sz="2200" b="1" u="none" strike="noStrike">
-                <a:solidFill>
-                  <a:srgbClr val="147D78"/>
-                </a:solidFill>
-                <a:effectLst/>
-                <a:uFillTx/>
-                <a:latin typeface="Arial"/>
-                <a:ea typeface="DejaVu Sans"/>
-              </a:rPr>
-              <a:t>los </a:t>
-            </a:r>
-            <a:r>
-              <a:rPr lang="es-CO" sz="2200" b="1" u="none" strike="noStrike">
-                <a:solidFill>
-                  <a:srgbClr val="147D78"/>
-                </a:solidFill>
-                <a:effectLst/>
-                <a:uFillTx/>
-                <a:latin typeface="Arial"/>
-                <a:ea typeface="DejaVu Sans"/>
-              </a:rPr>
-              <a:t>de </a:t>
-            </a:r>
-            <a:r>
-              <a:rPr lang="es-CO" sz="2200" b="1" u="none" strike="noStrike">
-                <a:solidFill>
-                  <a:srgbClr val="147D78"/>
-                </a:solidFill>
-                <a:effectLst/>
-                <a:uFillTx/>
-                <a:latin typeface="Arial"/>
-                <a:ea typeface="DejaVu Sans"/>
-              </a:rPr>
-              <a:t>la </a:t>
-            </a:r>
-            <a:r>
-              <a:rPr lang="es-CO" sz="2200" b="1" u="none" strike="noStrike">
-                <a:solidFill>
-                  <a:srgbClr val="147D78"/>
-                </a:solidFill>
-                <a:effectLst/>
-                <a:uFillTx/>
-                <a:latin typeface="Arial"/>
-                <a:ea typeface="DejaVu Sans"/>
-              </a:rPr>
-              <a:t>liter</a:t>
-            </a:r>
-            <a:r>
-              <a:rPr lang="es-CO" sz="2200" b="1" u="none" strike="noStrike">
-                <a:solidFill>
-                  <a:srgbClr val="147D78"/>
-                </a:solidFill>
-                <a:effectLst/>
-                <a:uFillTx/>
-                <a:latin typeface="Arial"/>
-                <a:ea typeface="DejaVu Sans"/>
-              </a:rPr>
-              <a:t>atur</a:t>
-            </a:r>
-            <a:r>
-              <a:rPr lang="es-CO" sz="2200" b="1" u="none" strike="noStrike">
-                <a:solidFill>
-                  <a:srgbClr val="147D78"/>
-                </a:solidFill>
-                <a:effectLst/>
-                <a:uFillTx/>
-                <a:latin typeface="Arial"/>
-                <a:ea typeface="DejaVu Sans"/>
-              </a:rPr>
-              <a:t>a.</a:t>
-            </a:r>
-            <a:endParaRPr lang="en-US" sz="2200" b="0" u="none" strike="noStrike">
-              <a:solidFill>
-                <a:srgbClr val="000000"/>
-              </a:solidFill>
-              <a:effectLst/>
-              <a:uFillTx/>
-              <a:latin typeface="Arial"/>
-            </a:endParaRPr>
+              <a:t>Probar cada componente, después el sistema completo.</a:t>
+            </a:r>
           </a:p>
         </p:txBody>
       </p:sp>
@@ -9242,28 +8966,8 @@
                 <a:latin typeface="Arial"/>
                 <a:ea typeface="DejaVu Sans"/>
               </a:rPr>
-              <a:t>Ejemplos de bancos: electricidad, clima y tráfico [11], [12]; </a:t>
-            </a:r>
-            <a:r>
-              <a:rPr lang="es-CO" sz="1700" b="0" u="none" strike="noStrike">
-                <a:solidFill>
-                  <a:srgbClr val="526372"/>
-                </a:solidFill>
-                <a:effectLst/>
-                <a:uFillTx/>
-                <a:latin typeface="Arial"/>
-                <a:ea typeface="DejaVu Sans"/>
-              </a:rPr>
-              <a:t>selección antes de evaluar.</a:t>
-            </a:r>
-            <a:endParaRPr lang="en-US" sz="1700" b="0" u="none" strike="noStrike">
-              <a:solidFill>
-                <a:srgbClr val="000000"/>
-              </a:solidFill>
-              <a:effectLst/>
-              <a:uFillTx/>
-              <a:latin typeface="Arial"/>
-            </a:endParaRPr>
+              <a:t>Datos de electricidad, clima y tráfico de la literatura [11], [12], además de datos financieros.</a:t>
+            </a:r>
           </a:p>
         </p:txBody>
       </p:sp>
@@ -9315,16 +9019,8 @@
                 <a:latin typeface="Arial"/>
                 <a:ea typeface="DejaVu Sans"/>
               </a:rPr>
-              <a:t>E0</a:t>
-            </a:r>
-            <a:endParaRPr lang="en-US" sz="2500" b="0" u="none" strike="noStrike">
-              <a:solidFill>
-                <a:srgbClr val="000000"/>
-              </a:solidFill>
-              <a:effectLst/>
-              <a:uFillTx/>
-              <a:latin typeface="Arial"/>
-            </a:endParaRPr>
+              <a:t>1</a:t>
+            </a:r>
           </a:p>
         </p:txBody>
       </p:sp>
@@ -9376,16 +9072,8 @@
                 <a:latin typeface="Arial"/>
                 <a:ea typeface="DejaVu Sans"/>
               </a:rPr>
-              <a:t>Mecanismos</a:t>
-            </a:r>
-            <a:endParaRPr lang="en-US" sz="2300" b="0" u="none" strike="noStrike">
-              <a:solidFill>
-                <a:srgbClr val="000000"/>
-              </a:solidFill>
-              <a:effectLst/>
-              <a:uFillTx/>
-              <a:latin typeface="Arial"/>
-            </a:endParaRPr>
+              <a:t>Señales controladas</a:t>
+            </a:r>
           </a:p>
         </p:txBody>
       </p:sp>
@@ -9425,7 +9113,7 @@
               </a:lnSpc>
             </a:pPr>
             <a:r>
-              <a:rPr lang="es-CO" sz="2000" b="0" u="none" strike="noStrike">
+              <a:rPr lang="es-CO" sz="1800" b="0" u="none" strike="noStrike">
                 <a:solidFill>
                   <a:srgbClr val="203344"/>
                 </a:solidFill>
@@ -9434,16 +9122,8 @@
                 <a:latin typeface="Arial"/>
                 <a:ea typeface="DejaVu Sans"/>
               </a:rPr>
-              <a:t>Sintéticos: ruido, ciclos y retardos.</a:t>
-            </a:r>
-            <a:endParaRPr lang="en-US" sz="2000" b="0" u="none" strike="noStrike">
-              <a:solidFill>
-                <a:srgbClr val="000000"/>
-              </a:solidFill>
-              <a:effectLst/>
-              <a:uFillTx/>
-              <a:latin typeface="Arial"/>
-            </a:endParaRPr>
+              <a:t>Crear series con ciclos, ruido y retardos.</a:t>
+            </a:r>
           </a:p>
           <a:p>
             <a:pPr>
@@ -9452,7 +9132,7 @@
               </a:lnSpc>
             </a:pPr>
             <a:r>
-              <a:rPr lang="es-CO" sz="2000" b="0" u="none" strike="noStrike">
+              <a:rPr lang="es-CO" sz="1800" b="0" u="none" strike="noStrike">
                 <a:solidFill>
                   <a:srgbClr val="203344"/>
                 </a:solidFill>
@@ -9461,16 +9141,8 @@
                 <a:latin typeface="Arial"/>
                 <a:ea typeface="DejaVu Sans"/>
               </a:rPr>
-              <a:t>Agrupación y fusión: H2 / H3.</a:t>
-            </a:r>
-            <a:endParaRPr lang="en-US" sz="2000" b="0" u="none" strike="noStrike">
-              <a:solidFill>
-                <a:srgbClr val="000000"/>
-              </a:solidFill>
-              <a:effectLst/>
-              <a:uFillTx/>
-              <a:latin typeface="Arial"/>
-            </a:endParaRPr>
+              <a:t>Comparar cómo agruparlas y fusionarlas.</a:t>
+            </a:r>
           </a:p>
         </p:txBody>
       </p:sp>
@@ -9522,16 +9194,8 @@
                 <a:latin typeface="Arial"/>
                 <a:ea typeface="DejaVu Sans"/>
               </a:rPr>
-              <a:t>E1</a:t>
-            </a:r>
-            <a:endParaRPr lang="en-US" sz="2500" b="0" u="none" strike="noStrike">
-              <a:solidFill>
-                <a:srgbClr val="000000"/>
-              </a:solidFill>
-              <a:effectLst/>
-              <a:uFillTx/>
-              <a:latin typeface="Arial"/>
-            </a:endParaRPr>
+              <a:t>2</a:t>
+            </a:r>
           </a:p>
         </p:txBody>
       </p:sp>
@@ -9583,16 +9247,8 @@
                 <a:latin typeface="Arial"/>
                 <a:ea typeface="DejaVu Sans"/>
               </a:rPr>
-              <a:t>Desarrollo público</a:t>
-            </a:r>
-            <a:endParaRPr lang="en-US" sz="2300" b="0" u="none" strike="noStrike">
-              <a:solidFill>
-                <a:srgbClr val="000000"/>
-              </a:solidFill>
-              <a:effectLst/>
-              <a:uFillTx/>
-              <a:latin typeface="Arial"/>
-            </a:endParaRPr>
+              <a:t>Comparar alternativas</a:t>
+            </a:r>
           </a:p>
         </p:txBody>
       </p:sp>
@@ -9632,7 +9288,7 @@
               </a:lnSpc>
             </a:pPr>
             <a:r>
-              <a:rPr lang="es-CO" sz="2000" b="0" u="none" strike="noStrike">
+              <a:rPr lang="es-CO" sz="1800" b="0" u="none" strike="noStrike">
                 <a:solidFill>
                   <a:srgbClr val="203344"/>
                 </a:solidFill>
@@ -9641,16 +9297,8 @@
                 <a:latin typeface="Arial"/>
                 <a:ea typeface="DejaVu Sans"/>
               </a:rPr>
-              <a:t>Fijar método, controles y presupuesto.</a:t>
-            </a:r>
-            <a:endParaRPr lang="en-US" sz="2000" b="0" u="none" strike="noStrike">
-              <a:solidFill>
-                <a:srgbClr val="000000"/>
-              </a:solidFill>
-              <a:effectLst/>
-              <a:uFillTx/>
-              <a:latin typeface="Arial"/>
-            </a:endParaRPr>
+              <a:t>Comparar modelos y transformaciones,</a:t>
+            </a:r>
           </a:p>
           <a:p>
             <a:pPr>
@@ -9659,7 +9307,7 @@
               </a:lnSpc>
             </a:pPr>
             <a:r>
-              <a:rPr lang="es-CO" sz="2000" b="0" u="none" strike="noStrike">
+              <a:rPr lang="es-CO" sz="1800" b="0" u="none" strike="noStrike">
                 <a:solidFill>
                   <a:srgbClr val="203344"/>
                 </a:solidFill>
@@ -9668,16 +9316,8 @@
                 <a:latin typeface="Arial"/>
                 <a:ea typeface="DejaVu Sans"/>
               </a:rPr>
-              <a:t>Transformaciones, modelos y R0 / R1 / R2.</a:t>
-            </a:r>
-            <a:endParaRPr lang="en-US" sz="2000" b="0" u="none" strike="noStrike">
-              <a:solidFill>
-                <a:srgbClr val="000000"/>
-              </a:solidFill>
-              <a:effectLst/>
-              <a:uFillTx/>
-              <a:latin typeface="Arial"/>
-            </a:endParaRPr>
+              <a:t>con y sin extractores preentrenados.</a:t>
+            </a:r>
           </a:p>
         </p:txBody>
       </p:sp>
@@ -9729,16 +9369,8 @@
                 <a:latin typeface="Arial"/>
                 <a:ea typeface="DejaVu Sans"/>
               </a:rPr>
-              <a:t>E2</a:t>
-            </a:r>
-            <a:endParaRPr lang="en-US" sz="2500" b="0" u="none" strike="noStrike">
-              <a:solidFill>
-                <a:srgbClr val="000000"/>
-              </a:solidFill>
-              <a:effectLst/>
-              <a:uFillTx/>
-              <a:latin typeface="Arial"/>
-            </a:endParaRPr>
+              <a:t>3</a:t>
+            </a:r>
           </a:p>
         </p:txBody>
       </p:sp>
@@ -9790,16 +9422,8 @@
                 <a:latin typeface="Arial"/>
                 <a:ea typeface="DejaVu Sans"/>
               </a:rPr>
-              <a:t>Confirmación pública</a:t>
-            </a:r>
-            <a:endParaRPr lang="en-US" sz="2300" b="0" u="none" strike="noStrike">
-              <a:solidFill>
-                <a:srgbClr val="000000"/>
-              </a:solidFill>
-              <a:effectLst/>
-              <a:uFillTx/>
-              <a:latin typeface="Arial"/>
-            </a:endParaRPr>
+              <a:t>Probar en otros datos</a:t>
+            </a:r>
           </a:p>
         </p:txBody>
       </p:sp>
@@ -9839,7 +9463,7 @@
               </a:lnSpc>
             </a:pPr>
             <a:r>
-              <a:rPr lang="es-CO" sz="2000" b="0" u="none" strike="noStrike">
+              <a:rPr lang="es-CO" sz="1800" b="0" u="none" strike="noStrike">
                 <a:solidFill>
                   <a:srgbClr val="203344"/>
                 </a:solidFill>
@@ -9848,16 +9472,8 @@
                 <a:latin typeface="Arial"/>
                 <a:ea typeface="DejaVu Sans"/>
               </a:rPr>
-              <a:t>Otras familias, no usadas en desarrollo.</a:t>
-            </a:r>
-            <a:endParaRPr lang="en-US" sz="2000" b="0" u="none" strike="noStrike">
-              <a:solidFill>
-                <a:srgbClr val="000000"/>
-              </a:solidFill>
-              <a:effectLst/>
-              <a:uFillTx/>
-              <a:latin typeface="Arial"/>
-            </a:endParaRPr>
+              <a:t>Evaluar la solución elegida sin reajustarla</a:t>
+            </a:r>
           </a:p>
           <a:p>
             <a:pPr>
@@ -9866,7 +9482,7 @@
               </a:lnSpc>
             </a:pPr>
             <a:r>
-              <a:rPr lang="es-CO" sz="2000" b="0" u="none" strike="noStrike">
+              <a:rPr lang="es-CO" sz="1800" b="0" u="none" strike="noStrike">
                 <a:solidFill>
                   <a:srgbClr val="203344"/>
                 </a:solidFill>
@@ -9875,16 +9491,8 @@
                 <a:latin typeface="Arial"/>
                 <a:ea typeface="DejaVu Sans"/>
               </a:rPr>
-              <a:t>Prueba exterior reservada: H1.</a:t>
-            </a:r>
-            <a:endParaRPr lang="en-US" sz="2000" b="0" u="none" strike="noStrike">
-              <a:solidFill>
-                <a:srgbClr val="000000"/>
-              </a:solidFill>
-              <a:effectLst/>
-              <a:uFillTx/>
-              <a:latin typeface="Arial"/>
-            </a:endParaRPr>
+              <a:t>en datos no usados para elegirla.</a:t>
+            </a:r>
           </a:p>
         </p:txBody>
       </p:sp>
@@ -9936,16 +9544,8 @@
                 <a:latin typeface="Arial"/>
                 <a:ea typeface="DejaVu Sans"/>
               </a:rPr>
-              <a:t>E3</a:t>
-            </a:r>
-            <a:endParaRPr lang="en-US" sz="2500" b="0" u="none" strike="noStrike">
-              <a:solidFill>
-                <a:srgbClr val="000000"/>
-              </a:solidFill>
-              <a:effectLst/>
-              <a:uFillTx/>
-              <a:latin typeface="Arial"/>
-            </a:endParaRPr>
+              <a:t>4</a:t>
+            </a:r>
           </a:p>
         </p:txBody>
       </p:sp>
@@ -9997,16 +9597,8 @@
                 <a:latin typeface="Arial"/>
                 <a:ea typeface="DejaVu Sans"/>
               </a:rPr>
-              <a:t>Aplicación financiera</a:t>
-            </a:r>
-            <a:endParaRPr lang="en-US" sz="2300" b="0" u="none" strike="noStrike">
-              <a:solidFill>
-                <a:srgbClr val="000000"/>
-              </a:solidFill>
-              <a:effectLst/>
-              <a:uFillTx/>
-              <a:latin typeface="Arial"/>
-            </a:endParaRPr>
+              <a:t>Evaluar en trading</a:t>
+            </a:r>
           </a:p>
         </p:txBody>
       </p:sp>
@@ -10046,7 +9638,7 @@
               </a:lnSpc>
             </a:pPr>
             <a:r>
-              <a:rPr lang="es-CO" sz="2000" b="0" u="none" strike="noStrike">
+              <a:rPr lang="es-CO" sz="1800" b="0" u="none" strike="noStrike">
                 <a:solidFill>
                   <a:srgbClr val="203344"/>
                 </a:solidFill>
@@ -10055,16 +9647,8 @@
                 <a:latin typeface="Arial"/>
                 <a:ea typeface="DejaVu Sans"/>
               </a:rPr>
-              <a:t>Pronóstico y RL con costes y latencia.</a:t>
-            </a:r>
-            <a:endParaRPr lang="en-US" sz="2000" b="0" u="none" strike="noStrike">
-              <a:solidFill>
-                <a:srgbClr val="000000"/>
-              </a:solidFill>
-              <a:effectLst/>
-              <a:uFillTx/>
-              <a:latin typeface="Arial"/>
-            </a:endParaRPr>
+              <a:t>Predecir precios y aprender decisiones.</a:t>
+            </a:r>
           </a:p>
           <a:p>
             <a:pPr>
@@ -10073,7 +9657,7 @@
               </a:lnSpc>
             </a:pPr>
             <a:r>
-              <a:rPr lang="es-CO" sz="2000" b="0" u="none" strike="noStrike">
+              <a:rPr lang="es-CO" sz="1800" b="0" u="none" strike="noStrike">
                 <a:solidFill>
                   <a:srgbClr val="203344"/>
                 </a:solidFill>
@@ -10082,16 +9666,8 @@
                 <a:latin typeface="Arial"/>
                 <a:ea typeface="DejaVu Sans"/>
               </a:rPr>
-              <a:t>Reentrenamiento y evaluación semanal.</a:t>
-            </a:r>
-            <a:endParaRPr lang="en-US" sz="2000" b="0" u="none" strike="noStrike">
-              <a:solidFill>
-                <a:srgbClr val="000000"/>
-              </a:solidFill>
-              <a:effectLst/>
-              <a:uFillTx/>
-              <a:latin typeface="Arial"/>
-            </a:endParaRPr>
+              <a:t>Simular costes y actualización semanal.</a:t>
+            </a:r>
           </a:p>
         </p:txBody>
       </p:sp>
@@ -10143,16 +9719,8 @@
                 <a:latin typeface="Arial"/>
                 <a:ea typeface="DejaVu Sans"/>
               </a:rPr>
-              <a:t>La generalización se contrasta entre familias; la utilidad financiera se evalúa por separado.</a:t>
-            </a:r>
-            <a:endParaRPr lang="en-US" sz="1700" b="0" u="none" strike="noStrike">
-              <a:solidFill>
-                <a:srgbClr val="000000"/>
-              </a:solidFill>
-              <a:effectLst/>
-              <a:uFillTx/>
-              <a:latin typeface="Arial"/>
-            </a:endParaRPr>
+              <a:t>Dos preguntas distintas: ¿mejora la predicción? ¿mejora también el resultado del trading?</a:t>
+            </a:r>
           </a:p>
         </p:txBody>
       </p:sp>
@@ -10277,16 +9845,8 @@
                 <a:latin typeface="Arial"/>
                 <a:ea typeface="DejaVu Sans"/>
               </a:rPr>
-              <a:t>COMPARABILIDAD</a:t>
-            </a:r>
-            <a:endParaRPr lang="en-US" sz="1000" b="0" u="none" strike="noStrike">
-              <a:solidFill>
-                <a:srgbClr val="000000"/>
-              </a:solidFill>
-              <a:effectLst/>
-              <a:uFillTx/>
-              <a:latin typeface="Arial"/>
-            </a:endParaRPr>
+              <a:t>EVALUACIÓN</a:t>
+            </a:r>
           </a:p>
         </p:txBody>
       </p:sp>
@@ -10338,16 +9898,8 @@
                 <a:latin typeface="Times New Roman"/>
                 <a:ea typeface="DejaVu Sans"/>
               </a:rPr>
-              <a:t>Comparar con la literatura, caso por caso</a:t>
-            </a:r>
-            <a:endParaRPr lang="en-US" sz="2900" b="1" u="none" strike="noStrike">
-              <a:solidFill>
-                <a:srgbClr val="000000"/>
-              </a:solidFill>
-              <a:effectLst/>
-              <a:uFillTx/>
-              <a:latin typeface="Arial"/>
-            </a:endParaRPr>
+              <a:t>Cómo sabremos si nuestra propuesta mejora</a:t>
+            </a:r>
           </a:p>
         </p:txBody>
       </p:sp>
@@ -10650,16 +10202,8 @@
                 <a:latin typeface="Arial"/>
                 <a:ea typeface="DejaVu Sans"/>
               </a:rPr>
-              <a:t>Primero reproducir la referencia; después contrastar nuestro método.</a:t>
-            </a:r>
-            <a:endParaRPr lang="en-US" sz="2300" b="0" u="none" strike="noStrike">
-              <a:solidFill>
-                <a:srgbClr val="000000"/>
-              </a:solidFill>
-              <a:effectLst/>
-              <a:uFillTx/>
-              <a:latin typeface="Arial"/>
-            </a:endParaRPr>
+              <a:t>Reproducir un modelo publicado y compararlo con nuestra propuesta.</a:t>
+            </a:r>
           </a:p>
         </p:txBody>
       </p:sp>
@@ -10754,16 +10298,8 @@
                 <a:latin typeface="Arial"/>
                 <a:ea typeface="DejaVu Sans"/>
               </a:rPr>
-              <a:t>MISMOS DATOS</a:t>
-            </a:r>
-            <a:endParaRPr lang="en-US" sz="1600" b="0" u="none" strike="noStrike">
-              <a:solidFill>
-                <a:srgbClr val="000000"/>
-              </a:solidFill>
-              <a:effectLst/>
-              <a:uFillTx/>
-              <a:latin typeface="Arial"/>
-            </a:endParaRPr>
+              <a:t>LOS MISMOS DATOS</a:t>
+            </a:r>
           </a:p>
         </p:txBody>
       </p:sp>
@@ -10812,16 +10348,8 @@
                 <a:latin typeface="Arial"/>
                 <a:ea typeface="DejaVu Sans"/>
               </a:rPr>
-              <a:t>Versión, partición, variables</a:t>
-            </a:r>
-            <a:endParaRPr lang="en-US" sz="2000" b="0" u="none" strike="noStrike">
-              <a:solidFill>
-                <a:srgbClr val="000000"/>
-              </a:solidFill>
-              <a:effectLst/>
-              <a:uFillTx/>
-              <a:latin typeface="Arial"/>
-            </a:endParaRPr>
+              <a:t>Mismas variables y fechas</a:t>
+            </a:r>
           </a:p>
           <a:p>
             <a:pPr>
@@ -10839,16 +10367,8 @@
                 <a:latin typeface="Arial"/>
                 <a:ea typeface="DejaVu Sans"/>
               </a:rPr>
-              <a:t>y objetivo de predicción.</a:t>
-            </a:r>
-            <a:endParaRPr lang="en-US" sz="2000" b="0" u="none" strike="noStrike">
-              <a:solidFill>
-                <a:srgbClr val="000000"/>
-              </a:solidFill>
-              <a:effectLst/>
-              <a:uFillTx/>
-              <a:latin typeface="Arial"/>
-            </a:endParaRPr>
+              <a:t>para entrenar y evaluar.</a:t>
+            </a:r>
           </a:p>
         </p:txBody>
       </p:sp>
@@ -10943,16 +10463,8 @@
                 <a:latin typeface="Arial"/>
                 <a:ea typeface="DejaVu Sans"/>
               </a:rPr>
-              <a:t>MISMA TAREA</a:t>
-            </a:r>
-            <a:endParaRPr lang="en-US" sz="1600" b="0" u="none" strike="noStrike">
-              <a:solidFill>
-                <a:srgbClr val="000000"/>
-              </a:solidFill>
-              <a:effectLst/>
-              <a:uFillTx/>
-              <a:latin typeface="Arial"/>
-            </a:endParaRPr>
+              <a:t>LA MISMA PREDICCIÓN</a:t>
+            </a:r>
           </a:p>
         </p:txBody>
       </p:sp>
@@ -11001,16 +10513,8 @@
                 <a:latin typeface="Arial"/>
                 <a:ea typeface="DejaVu Sans"/>
               </a:rPr>
-              <a:t>Frecuencia y horizonte.</a:t>
-            </a:r>
-            <a:endParaRPr lang="en-US" sz="2000" b="0" u="none" strike="noStrike">
-              <a:solidFill>
-                <a:srgbClr val="000000"/>
-              </a:solidFill>
-              <a:effectLst/>
-              <a:uFillTx/>
-              <a:latin typeface="Arial"/>
-            </a:endParaRPr>
+              <a:t>Mismo valor a predecir,</a:t>
+            </a:r>
           </a:p>
           <a:p>
             <a:pPr>
@@ -11028,16 +10532,8 @@
                 <a:latin typeface="Arial"/>
                 <a:ea typeface="DejaVu Sans"/>
               </a:rPr>
-              <a:t>Ventana, escalado y faltantes.</a:t>
-            </a:r>
-            <a:endParaRPr lang="en-US" sz="2000" b="0" u="none" strike="noStrike">
-              <a:solidFill>
-                <a:srgbClr val="000000"/>
-              </a:solidFill>
-              <a:effectLst/>
-              <a:uFillTx/>
-              <a:latin typeface="Arial"/>
-            </a:endParaRPr>
+              <a:t>horizonte e información disponible.</a:t>
+            </a:r>
           </a:p>
         </p:txBody>
       </p:sp>
@@ -11132,16 +10628,8 @@
                 <a:latin typeface="Arial"/>
                 <a:ea typeface="DejaVu Sans"/>
               </a:rPr>
-              <a:t>MISMA MEDIDA</a:t>
-            </a:r>
-            <a:endParaRPr lang="en-US" sz="1600" b="0" u="none" strike="noStrike">
-              <a:solidFill>
-                <a:srgbClr val="000000"/>
-              </a:solidFill>
-              <a:effectLst/>
-              <a:uFillTx/>
-              <a:latin typeface="Arial"/>
-            </a:endParaRPr>
+              <a:t>EL MISMO ERROR</a:t>
+            </a:r>
           </a:p>
         </p:txBody>
       </p:sp>
@@ -11190,16 +10678,8 @@
                 <a:latin typeface="Arial"/>
                 <a:ea typeface="DejaVu Sans"/>
               </a:rPr>
-              <a:t>Métrica, espacio de salida</a:t>
-            </a:r>
-            <a:endParaRPr lang="en-US" sz="2000" b="0" u="none" strike="noStrike">
-              <a:solidFill>
-                <a:srgbClr val="000000"/>
-              </a:solidFill>
-              <a:effectLst/>
-              <a:uFillTx/>
-              <a:latin typeface="Arial"/>
-            </a:endParaRPr>
+              <a:t>Misma fórmula y normalización</a:t>
+            </a:r>
           </a:p>
           <a:p>
             <a:pPr>
@@ -11217,16 +10697,8 @@
                 <a:latin typeface="Arial"/>
                 <a:ea typeface="DejaVu Sans"/>
               </a:rPr>
-              <a:t>y funciones de fintness.</a:t>
-            </a:r>
-            <a:endParaRPr lang="en-US" sz="2000" b="0" u="none" strike="noStrike">
-              <a:solidFill>
-                <a:srgbClr val="000000"/>
-              </a:solidFill>
-              <a:effectLst/>
-              <a:uFillTx/>
-              <a:latin typeface="Arial"/>
-            </a:endParaRPr>
+              <a:t>que el estudio de referencia.</a:t>
+            </a:r>
           </a:p>
         </p:txBody>
       </p:sp>
@@ -11321,16 +10793,8 @@
                 <a:latin typeface="Arial"/>
                 <a:ea typeface="DejaVu Sans"/>
               </a:rPr>
-              <a:t>Pronóstico [11], [12]</a:t>
-            </a:r>
-            <a:endParaRPr lang="en-US" sz="2200" b="0" u="none" strike="noStrike">
-              <a:solidFill>
-                <a:srgbClr val="000000"/>
-              </a:solidFill>
-              <a:effectLst/>
-              <a:uFillTx/>
-              <a:latin typeface="Arial"/>
-            </a:endParaRPr>
+              <a:t>Predicción [11], [12]</a:t>
+            </a:r>
           </a:p>
         </p:txBody>
       </p:sp>
@@ -11370,7 +10834,7 @@
               </a:lnSpc>
             </a:pPr>
             <a:r>
-              <a:rPr lang="es-CO" sz="1900" b="0" u="none" strike="noStrike">
+              <a:rPr lang="es-CO" sz="1650" b="0" u="none" strike="noStrike">
                 <a:solidFill>
                   <a:srgbClr val="203344"/>
                 </a:solidFill>
@@ -11379,16 +10843,8 @@
                 <a:latin typeface="Arial"/>
                 <a:ea typeface="DejaVu Sans"/>
               </a:rPr>
-              <a:t>MAE / MSE en la escala publicada.</a:t>
-            </a:r>
-            <a:endParaRPr lang="en-US" sz="1900" b="0" u="none" strike="noStrike">
-              <a:solidFill>
-                <a:srgbClr val="000000"/>
-              </a:solidFill>
-              <a:effectLst/>
-              <a:uFillTx/>
-              <a:latin typeface="Arial"/>
-            </a:endParaRPr>
+              <a:t>Comparar MAE y MSE con el modelo publicado</a:t>
+            </a:r>
           </a:p>
           <a:p>
             <a:pPr>
@@ -11397,7 +10853,7 @@
               </a:lnSpc>
             </a:pPr>
             <a:r>
-              <a:rPr lang="es-CO" sz="1900" b="0" u="none" strike="noStrike">
+              <a:rPr lang="es-CO" sz="1650" b="0" u="none" strike="noStrike">
                 <a:solidFill>
                   <a:srgbClr val="203344"/>
                 </a:solidFill>
@@ -11406,16 +10862,27 @@
                 <a:latin typeface="Arial"/>
                 <a:ea typeface="DejaVu Sans"/>
               </a:rPr>
-              <a:t>Naïve ; skill = 1 − error / error naïve.</a:t>
-            </a:r>
-            <a:endParaRPr lang="en-US" sz="1900" b="0" u="none" strike="noStrike">
-              <a:solidFill>
-                <a:srgbClr val="000000"/>
-              </a:solidFill>
-              <a:effectLst/>
-              <a:uFillTx/>
-              <a:latin typeface="Arial"/>
-            </a:endParaRPr>
+              <a:t>y con la predicción de referencia:</a:t>
+            </a:r>
+          </a:p>
+          <a:p>
+            <a:pPr>
+              <a:lnSpc>
+                <a:spcPct val="105000"/>
+              </a:lnSpc>
+            </a:pPr>
+            <a:r>
+              <a:rPr lang="es-CO" sz="1650" b="0" u="none" strike="noStrike">
+                <a:solidFill>
+                  <a:srgbClr val="203344"/>
+                </a:solidFill>
+                <a:effectLst/>
+                <a:uFillTx/>
+                <a:latin typeface="Arial"/>
+                <a:ea typeface="DejaVu Sans"/>
+              </a:rPr>
+              <a:t>que el valor actual no cambia.</a:t>
+            </a:r>
           </a:p>
         </p:txBody>
       </p:sp>
@@ -11458,7 +10925,7 @@
               </a:spcAft>
             </a:pPr>
             <a:r>
-              <a:rPr lang="es-CO" sz="2200" b="1" u="none" strike="noStrike">
+              <a:rPr lang="es-CO" sz="2000" b="1" u="none" strike="noStrike">
                 <a:solidFill>
                   <a:srgbClr val="203344"/>
                 </a:solidFill>
@@ -11467,16 +10934,8 @@
                 <a:latin typeface="Arial"/>
                 <a:ea typeface="DejaVu Sans"/>
               </a:rPr>
-              <a:t>Trading y RL</a:t>
-            </a:r>
-            <a:endParaRPr lang="en-US" sz="2200" b="0" u="none" strike="noStrike">
-              <a:solidFill>
-                <a:srgbClr val="000000"/>
-              </a:solidFill>
-              <a:effectLst/>
-              <a:uFillTx/>
-              <a:latin typeface="Arial"/>
-            </a:endParaRPr>
+              <a:t>Trading y aprendizaje por refuerzo</a:t>
+            </a:r>
           </a:p>
         </p:txBody>
       </p:sp>
@@ -11516,7 +10975,7 @@
               </a:lnSpc>
             </a:pPr>
             <a:r>
-              <a:rPr lang="es-CO" sz="1900" b="0" u="none" strike="noStrike">
+              <a:rPr lang="es-CO" sz="1650" b="0" u="none" strike="noStrike">
                 <a:solidFill>
                   <a:srgbClr val="203344"/>
                 </a:solidFill>
@@ -11525,16 +10984,8 @@
                 <a:latin typeface="Arial"/>
                 <a:ea typeface="DejaVu Sans"/>
               </a:rPr>
-              <a:t>Beneficio neto, Sharpe y caída máxima.</a:t>
-            </a:r>
-            <a:endParaRPr lang="en-US" sz="1900" b="0" u="none" strike="noStrike">
-              <a:solidFill>
-                <a:srgbClr val="000000"/>
-              </a:solidFill>
-              <a:effectLst/>
-              <a:uFillTx/>
-              <a:latin typeface="Arial"/>
-            </a:endParaRPr>
+              <a:t>Comparar beneficio neto, Sharpe y caída máxima.</a:t>
+            </a:r>
           </a:p>
           <a:p>
             <a:pPr>
@@ -11543,7 +10994,7 @@
               </a:lnSpc>
             </a:pPr>
             <a:r>
-              <a:rPr lang="es-CO" sz="1900" b="0" u="none" strike="noStrike">
+              <a:rPr lang="es-CO" sz="1650" b="0" u="none" strike="noStrike">
                 <a:solidFill>
                   <a:srgbClr val="203344"/>
                 </a:solidFill>
@@ -11552,16 +11003,27 @@
                 <a:latin typeface="Arial"/>
                 <a:ea typeface="DejaVu Sans"/>
               </a:rPr>
-              <a:t>Iguales periodos, costes y ejecución.</a:t>
-            </a:r>
-            <a:endParaRPr lang="en-US" sz="1900" b="0" u="none" strike="noStrike">
-              <a:solidFill>
-                <a:srgbClr val="000000"/>
-              </a:solidFill>
-              <a:effectLst/>
-              <a:uFillTx/>
-              <a:latin typeface="Arial"/>
-            </a:endParaRPr>
+              <a:t>Usar las mismas fechas, costes</a:t>
+            </a:r>
+          </a:p>
+          <a:p>
+            <a:pPr>
+              <a:lnSpc>
+                <a:spcPct val="105000"/>
+              </a:lnSpc>
+            </a:pPr>
+            <a:r>
+              <a:rPr lang="es-CO" sz="1650" b="0" u="none" strike="noStrike">
+                <a:solidFill>
+                  <a:srgbClr val="203344"/>
+                </a:solidFill>
+                <a:effectLst/>
+                <a:uFillTx/>
+                <a:latin typeface="Arial"/>
+                <a:ea typeface="DejaVu Sans"/>
+              </a:rPr>
+              <a:t>y reglas de ejecución.</a:t>
+            </a:r>
           </a:p>
         </p:txBody>
       </p:sp>
@@ -11610,16 +11072,8 @@
                 <a:latin typeface="Arial"/>
                 <a:ea typeface="DejaVu Sans"/>
               </a:rPr>
-              <a:t>Selección interna y prueba reservada [13]; semillas e incertidumbre temporal.</a:t>
-            </a:r>
-            <a:endParaRPr lang="en-US" sz="1650" b="0" u="none" strike="noStrike">
-              <a:solidFill>
-                <a:srgbClr val="000000"/>
-              </a:solidFill>
-              <a:effectLst/>
-              <a:uFillTx/>
-              <a:latin typeface="Arial"/>
-            </a:endParaRPr>
+              <a:t>Elegir la configuración sin consultar los datos de prueba final [13]. Repetir entrenamientos.</a:t>
+            </a:r>
           </a:p>
           <a:p>
             <a:pPr>
@@ -11637,16 +11091,8 @@
                 <a:latin typeface="Arial"/>
                 <a:ea typeface="DejaVu Sans"/>
               </a:rPr>
-              <a:t>Si cambia el protocolo: reejecución emparejada, no comparación directa con la cifra publicada.</a:t>
-            </a:r>
-            <a:endParaRPr lang="en-US" sz="1650" b="0" u="none" strike="noStrike">
-              <a:solidFill>
-                <a:srgbClr val="000000"/>
-              </a:solidFill>
-              <a:effectLst/>
-              <a:uFillTx/>
-              <a:latin typeface="Arial"/>
-            </a:endParaRPr>
+              <a:t>Si cambia la tarea del artículo, ejecutar también su modelo en nuestra tarea.</a:t>
+            </a:r>
           </a:p>
         </p:txBody>
       </p:sp>

</xml_diff>